<commit_message>
docs: restore safewizpro local notes
</commit_message>
<xml_diff>
--- a/docs/경광등_Device_데이타_자료.pptx
+++ b/docs/경광등_Device_데이타_자료.pptx
@@ -262,7 +262,7 @@
           <a:p>
             <a:fld id="{F30C5925-957C-4246-9F3B-66AC733F3497}" type="datetimeFigureOut">
               <a:rPr lang="ko-KR" altLang="en-US" smtClean="0"/>
-              <a:t>2026-04-23</a:t>
+              <a:t>2026-06-17</a:t>
             </a:fld>
             <a:endParaRPr lang="ko-KR" altLang="en-US"/>
           </a:p>
@@ -460,7 +460,7 @@
           <a:p>
             <a:fld id="{F30C5925-957C-4246-9F3B-66AC733F3497}" type="datetimeFigureOut">
               <a:rPr lang="ko-KR" altLang="en-US" smtClean="0"/>
-              <a:t>2026-04-23</a:t>
+              <a:t>2026-06-17</a:t>
             </a:fld>
             <a:endParaRPr lang="ko-KR" altLang="en-US"/>
           </a:p>
@@ -668,7 +668,7 @@
           <a:p>
             <a:fld id="{F30C5925-957C-4246-9F3B-66AC733F3497}" type="datetimeFigureOut">
               <a:rPr lang="ko-KR" altLang="en-US" smtClean="0"/>
-              <a:t>2026-04-23</a:t>
+              <a:t>2026-06-17</a:t>
             </a:fld>
             <a:endParaRPr lang="ko-KR" altLang="en-US"/>
           </a:p>
@@ -866,7 +866,7 @@
           <a:p>
             <a:fld id="{F30C5925-957C-4246-9F3B-66AC733F3497}" type="datetimeFigureOut">
               <a:rPr lang="ko-KR" altLang="en-US" smtClean="0"/>
-              <a:t>2026-04-23</a:t>
+              <a:t>2026-06-17</a:t>
             </a:fld>
             <a:endParaRPr lang="ko-KR" altLang="en-US"/>
           </a:p>
@@ -1141,7 +1141,7 @@
           <a:p>
             <a:fld id="{F30C5925-957C-4246-9F3B-66AC733F3497}" type="datetimeFigureOut">
               <a:rPr lang="ko-KR" altLang="en-US" smtClean="0"/>
-              <a:t>2026-04-23</a:t>
+              <a:t>2026-06-17</a:t>
             </a:fld>
             <a:endParaRPr lang="ko-KR" altLang="en-US"/>
           </a:p>
@@ -1406,7 +1406,7 @@
           <a:p>
             <a:fld id="{F30C5925-957C-4246-9F3B-66AC733F3497}" type="datetimeFigureOut">
               <a:rPr lang="ko-KR" altLang="en-US" smtClean="0"/>
-              <a:t>2026-04-23</a:t>
+              <a:t>2026-06-17</a:t>
             </a:fld>
             <a:endParaRPr lang="ko-KR" altLang="en-US"/>
           </a:p>
@@ -1818,7 +1818,7 @@
           <a:p>
             <a:fld id="{F30C5925-957C-4246-9F3B-66AC733F3497}" type="datetimeFigureOut">
               <a:rPr lang="ko-KR" altLang="en-US" smtClean="0"/>
-              <a:t>2026-04-23</a:t>
+              <a:t>2026-06-17</a:t>
             </a:fld>
             <a:endParaRPr lang="ko-KR" altLang="en-US"/>
           </a:p>
@@ -1959,7 +1959,7 @@
           <a:p>
             <a:fld id="{F30C5925-957C-4246-9F3B-66AC733F3497}" type="datetimeFigureOut">
               <a:rPr lang="ko-KR" altLang="en-US" smtClean="0"/>
-              <a:t>2026-04-23</a:t>
+              <a:t>2026-06-17</a:t>
             </a:fld>
             <a:endParaRPr lang="ko-KR" altLang="en-US"/>
           </a:p>
@@ -2072,7 +2072,7 @@
           <a:p>
             <a:fld id="{F30C5925-957C-4246-9F3B-66AC733F3497}" type="datetimeFigureOut">
               <a:rPr lang="ko-KR" altLang="en-US" smtClean="0"/>
-              <a:t>2026-04-23</a:t>
+              <a:t>2026-06-17</a:t>
             </a:fld>
             <a:endParaRPr lang="ko-KR" altLang="en-US"/>
           </a:p>
@@ -2383,7 +2383,7 @@
           <a:p>
             <a:fld id="{F30C5925-957C-4246-9F3B-66AC733F3497}" type="datetimeFigureOut">
               <a:rPr lang="ko-KR" altLang="en-US" smtClean="0"/>
-              <a:t>2026-04-23</a:t>
+              <a:t>2026-06-17</a:t>
             </a:fld>
             <a:endParaRPr lang="ko-KR" altLang="en-US"/>
           </a:p>
@@ -2671,7 +2671,7 @@
           <a:p>
             <a:fld id="{F30C5925-957C-4246-9F3B-66AC733F3497}" type="datetimeFigureOut">
               <a:rPr lang="ko-KR" altLang="en-US" smtClean="0"/>
-              <a:t>2026-04-23</a:t>
+              <a:t>2026-06-17</a:t>
             </a:fld>
             <a:endParaRPr lang="ko-KR" altLang="en-US"/>
           </a:p>
@@ -2912,7 +2912,7 @@
           <a:p>
             <a:fld id="{F30C5925-957C-4246-9F3B-66AC733F3497}" type="datetimeFigureOut">
               <a:rPr lang="ko-KR" altLang="en-US" smtClean="0"/>
-              <a:t>2026-04-23</a:t>
+              <a:t>2026-06-17</a:t>
             </a:fld>
             <a:endParaRPr lang="ko-KR" altLang="en-US"/>
           </a:p>
@@ -3992,7 +3992,15 @@
           <a:p>
             <a:r>
               <a:rPr lang="ko-KR" altLang="en-US" dirty="0"/>
-              <a:t>00009 : 0 </a:t>
+              <a:t>0000</a:t>
+            </a:r>
+            <a:r>
+              <a:rPr lang="en-US" altLang="ko-KR" dirty="0"/>
+              <a:t>8</a:t>
+            </a:r>
+            <a:r>
+              <a:rPr lang="ko-KR" altLang="en-US" dirty="0"/>
+              <a:t> : 0 </a:t>
             </a:r>
             <a:r>
               <a:rPr lang="ko-KR" altLang="en-US" dirty="0" err="1"/>
@@ -4007,7 +4015,15 @@
           <a:p>
             <a:r>
               <a:rPr lang="ko-KR" altLang="en-US" dirty="0"/>
-              <a:t>00010 : 1 </a:t>
+              <a:t>000</a:t>
+            </a:r>
+            <a:r>
+              <a:rPr lang="en-US" altLang="ko-KR" dirty="0"/>
+              <a:t>09</a:t>
+            </a:r>
+            <a:r>
+              <a:rPr lang="ko-KR" altLang="en-US" dirty="0"/>
+              <a:t> : 1 </a:t>
             </a:r>
             <a:r>
               <a:rPr lang="ko-KR" altLang="en-US" dirty="0" err="1"/>
@@ -4022,7 +4038,15 @@
           <a:p>
             <a:r>
               <a:rPr lang="ko-KR" altLang="en-US" dirty="0"/>
-              <a:t>00011 : 2 </a:t>
+              <a:t>0001</a:t>
+            </a:r>
+            <a:r>
+              <a:rPr lang="en-US" altLang="ko-KR" dirty="0"/>
+              <a:t>0</a:t>
+            </a:r>
+            <a:r>
+              <a:rPr lang="ko-KR" altLang="en-US" dirty="0"/>
+              <a:t> : 2 </a:t>
             </a:r>
             <a:r>
               <a:rPr lang="ko-KR" altLang="en-US" dirty="0" err="1"/>
@@ -4033,7 +4057,15 @@
           <a:p>
             <a:r>
               <a:rPr lang="ko-KR" altLang="en-US" b="1" dirty="0"/>
-              <a:t>00012 : 3 </a:t>
+              <a:t>0001</a:t>
+            </a:r>
+            <a:r>
+              <a:rPr lang="en-US" altLang="ko-KR" b="1" dirty="0"/>
+              <a:t>1</a:t>
+            </a:r>
+            <a:r>
+              <a:rPr lang="ko-KR" altLang="en-US" b="1" dirty="0"/>
+              <a:t> : 3 </a:t>
             </a:r>
             <a:r>
               <a:rPr lang="ko-KR" altLang="en-US" b="1" dirty="0" err="1"/>

</xml_diff>